<commit_message>
feat: enhance slide design with new glass and transition functions
Co-authored-by: VIVEK KUMAR GUPTA <271483430+aman123825@users.noreply.github.com>
</commit_message>
<xml_diff>
--- a/docs/Agrobot_IDEAS_Level_1_Kickoff_14_Aug_2026.pptx
+++ b/docs/Agrobot_IDEAS_Level_1_Kickoff_14_Aug_2026.pptx
@@ -3462,7 +3462,96 @@
       </p:sp>
       <p:sp>
         <p:nvSpPr>
-          <p:cNvPr id="10" name="TextBox 9"/>
+          <p:cNvPr id="10" name="Rounded Rectangle 9"/>
+          <p:cNvSpPr/>
+          <p:nvPr/>
+        </p:nvSpPr>
+        <p:spPr>
+          <a:xfrm>
+            <a:off x="4224528" y="658368"/>
+            <a:ext cx="7360920" cy="5486400"/>
+          </a:xfrm>
+          <a:prstGeom prst="roundRect">
+            <a:avLst>
+              <a:gd name="adj" fmla="val 8000"/>
+            </a:avLst>
+          </a:prstGeom>
+          <a:solidFill>
+            <a:srgbClr val="FFFFFF"/>
+          </a:solidFill>
+          <a:ln w="10160">
+            <a:solidFill>
+              <a:srgbClr val="64827D"/>
+            </a:solidFill>
+          </a:ln>
+          <a:effectLst>
+            <a:outerShdw blurRad="63500" dist="25400" dir="2700000" algn="ctr" rotWithShape="0">
+              <a:srgbClr val="0F1D26">
+                <a:alpha val="18000"/>
+              </a:srgbClr>
+            </a:outerShdw>
+          </a:effectLst>
+        </p:spPr>
+        <p:style>
+          <a:lnRef idx="1">
+            <a:schemeClr val="accent1"/>
+          </a:lnRef>
+          <a:fillRef idx="3">
+            <a:schemeClr val="accent1"/>
+          </a:fillRef>
+          <a:effectRef idx="2">
+            <a:schemeClr val="accent1"/>
+          </a:effectRef>
+          <a:fontRef idx="minor">
+            <a:schemeClr val="lt1"/>
+          </a:fontRef>
+        </p:style>
+        <p:txBody>
+          <a:bodyPr rtlCol="0" anchor="ctr"/>
+          <a:lstStyle/>
+          <a:p>
+            <a:pPr algn="ctr"/>
+          </a:p>
+        </p:txBody>
+      </p:sp>
+      <p:sp>
+        <p:nvSpPr>
+          <p:cNvPr id="11" name="TextBox 10"/>
+          <p:cNvSpPr txBox="1"/>
+          <p:nvPr/>
+        </p:nvSpPr>
+        <p:spPr>
+          <a:xfrm>
+            <a:off x="10195560" y="896112"/>
+            <a:ext cx="1005840" cy="219456"/>
+          </a:xfrm>
+          <a:prstGeom prst="rect">
+            <a:avLst/>
+          </a:prstGeom>
+          <a:noFill/>
+        </p:spPr>
+        <p:txBody>
+          <a:bodyPr wrap="square" lIns="0" rIns="0" tIns="0" bIns="0" anchor="t">
+            <a:spAutoFit/>
+          </a:bodyPr>
+          <a:lstStyle/>
+          <a:p>
+            <a:pPr algn="r"/>
+            <a:r>
+              <a:rPr sz="800" b="1" i="0">
+                <a:solidFill>
+                  <a:srgbClr val="BECDC8"/>
+                </a:solidFill>
+                <a:latin typeface="Aptos"/>
+              </a:rPr>
+              <a:t>PRE-KICKOFF</a:t>
+            </a:r>
+          </a:p>
+        </p:txBody>
+      </p:sp>
+      <p:sp>
+        <p:nvSpPr>
+          <p:cNvPr id="12" name="TextBox 11"/>
           <p:cNvSpPr txBox="1"/>
           <p:nvPr/>
         </p:nvSpPr>
@@ -3497,7 +3586,7 @@
       </p:sp>
       <p:sp>
         <p:nvSpPr>
-          <p:cNvPr id="11" name="Rounded Rectangle 10"/>
+          <p:cNvPr id="13" name="Rounded Rectangle 12"/>
           <p:cNvSpPr/>
           <p:nvPr/>
         </p:nvSpPr>
@@ -3544,7 +3633,7 @@
       </p:sp>
       <p:sp>
         <p:nvSpPr>
-          <p:cNvPr id="12" name="TextBox 11"/>
+          <p:cNvPr id="14" name="TextBox 13"/>
           <p:cNvSpPr txBox="1"/>
           <p:nvPr/>
         </p:nvSpPr>
@@ -3579,7 +3668,7 @@
       </p:sp>
       <p:sp>
         <p:nvSpPr>
-          <p:cNvPr id="13" name="TextBox 12"/>
+          <p:cNvPr id="15" name="TextBox 14"/>
           <p:cNvSpPr txBox="1"/>
           <p:nvPr/>
         </p:nvSpPr>
@@ -3614,7 +3703,7 @@
       </p:sp>
       <p:sp>
         <p:nvSpPr>
-          <p:cNvPr id="14" name="TextBox 13"/>
+          <p:cNvPr id="16" name="TextBox 15"/>
           <p:cNvSpPr txBox="1"/>
           <p:nvPr/>
         </p:nvSpPr>
@@ -3650,7 +3739,7 @@
       </p:sp>
       <p:sp>
         <p:nvSpPr>
-          <p:cNvPr id="15" name="TextBox 14"/>
+          <p:cNvPr id="17" name="TextBox 16"/>
           <p:cNvSpPr txBox="1"/>
           <p:nvPr/>
         </p:nvSpPr>
@@ -3685,7 +3774,7 @@
       </p:sp>
       <p:sp>
         <p:nvSpPr>
-          <p:cNvPr id="16" name="TextBox 15"/>
+          <p:cNvPr id="18" name="TextBox 17"/>
           <p:cNvSpPr txBox="1"/>
           <p:nvPr/>
         </p:nvSpPr>
@@ -3721,7 +3810,7 @@
       </p:sp>
       <p:sp>
         <p:nvSpPr>
-          <p:cNvPr id="17" name="TextBox 16"/>
+          <p:cNvPr id="19" name="TextBox 18"/>
           <p:cNvSpPr txBox="1"/>
           <p:nvPr/>
         </p:nvSpPr>
@@ -3756,7 +3845,7 @@
       </p:sp>
       <p:sp>
         <p:nvSpPr>
-          <p:cNvPr id="18" name="Rectangle 17"/>
+          <p:cNvPr id="20" name="Rectangle 19"/>
           <p:cNvSpPr/>
           <p:nvPr/>
         </p:nvSpPr>
@@ -3801,7 +3890,7 @@
       </p:sp>
       <p:sp>
         <p:nvSpPr>
-          <p:cNvPr id="19" name="TextBox 18"/>
+          <p:cNvPr id="21" name="TextBox 20"/>
           <p:cNvSpPr txBox="1"/>
           <p:nvPr/>
         </p:nvSpPr>
@@ -3836,7 +3925,7 @@
       </p:sp>
       <p:sp>
         <p:nvSpPr>
-          <p:cNvPr id="20" name="TextBox 19"/>
+          <p:cNvPr id="22" name="TextBox 21"/>
           <p:cNvSpPr txBox="1"/>
           <p:nvPr/>
         </p:nvSpPr>
@@ -3871,7 +3960,7 @@
       </p:sp>
       <p:sp>
         <p:nvSpPr>
-          <p:cNvPr id="21" name="TextBox 20"/>
+          <p:cNvPr id="23" name="TextBox 22"/>
           <p:cNvSpPr txBox="1"/>
           <p:nvPr/>
         </p:nvSpPr>
@@ -3909,6 +3998,9 @@
   <p:clrMapOvr>
     <a:masterClrMapping/>
   </p:clrMapOvr>
+  <p:transition spd="med" advClick="1" dur="850">
+    <p:fade/>
+  </p:transition>
 </p:sld>
 </file>
 
@@ -4204,11 +4296,18 @@
           <a:solidFill>
             <a:srgbClr val="FFFFFF"/>
           </a:solidFill>
-          <a:ln w="12700">
+          <a:ln w="10160">
             <a:solidFill>
-              <a:srgbClr val="DCE2D8"/>
+              <a:srgbClr val="DBE2DC"/>
             </a:solidFill>
           </a:ln>
+          <a:effectLst>
+            <a:outerShdw blurRad="63500" dist="25400" dir="2700000" algn="ctr" rotWithShape="0">
+              <a:srgbClr val="0F1D26">
+                <a:alpha val="18000"/>
+              </a:srgbClr>
+            </a:outerShdw>
+          </a:effectLst>
         </p:spPr>
         <p:style>
           <a:lnRef idx="1">
@@ -5314,6 +5413,9 @@
   <p:clrMapOvr>
     <a:masterClrMapping/>
   </p:clrMapOvr>
+  <p:transition spd="med" advClick="1" dur="700">
+    <p:fade/>
+  </p:transition>
 </p:sld>
 </file>
 
@@ -5691,11 +5793,18 @@
           <a:solidFill>
             <a:srgbClr val="FFFFFF"/>
           </a:solidFill>
-          <a:ln w="12700">
+          <a:ln w="10160">
             <a:solidFill>
-              <a:srgbClr val="DCE2D8"/>
+              <a:srgbClr val="DBE2DC"/>
             </a:solidFill>
           </a:ln>
+          <a:effectLst>
+            <a:outerShdw blurRad="63500" dist="25400" dir="2700000" algn="ctr" rotWithShape="0">
+              <a:srgbClr val="0F1D26">
+                <a:alpha val="18000"/>
+              </a:srgbClr>
+            </a:outerShdw>
+          </a:effectLst>
         </p:spPr>
         <p:style>
           <a:lnRef idx="1">
@@ -5843,11 +5952,18 @@
           <a:solidFill>
             <a:srgbClr val="FFFFFF"/>
           </a:solidFill>
-          <a:ln w="12700">
+          <a:ln w="10160">
             <a:solidFill>
-              <a:srgbClr val="DCE2D8"/>
+              <a:srgbClr val="DBE2DC"/>
             </a:solidFill>
           </a:ln>
+          <a:effectLst>
+            <a:outerShdw blurRad="63500" dist="25400" dir="2700000" algn="ctr" rotWithShape="0">
+              <a:srgbClr val="0F1D26">
+                <a:alpha val="18000"/>
+              </a:srgbClr>
+            </a:outerShdw>
+          </a:effectLst>
         </p:spPr>
         <p:style>
           <a:lnRef idx="1">
@@ -5995,11 +6111,18 @@
           <a:solidFill>
             <a:srgbClr val="FFFFFF"/>
           </a:solidFill>
-          <a:ln w="12700">
+          <a:ln w="10160">
             <a:solidFill>
-              <a:srgbClr val="DCE2D8"/>
+              <a:srgbClr val="DBE2DC"/>
             </a:solidFill>
           </a:ln>
+          <a:effectLst>
+            <a:outerShdw blurRad="63500" dist="25400" dir="2700000" algn="ctr" rotWithShape="0">
+              <a:srgbClr val="0F1D26">
+                <a:alpha val="18000"/>
+              </a:srgbClr>
+            </a:outerShdw>
+          </a:effectLst>
         </p:spPr>
         <p:style>
           <a:lnRef idx="1">
@@ -6147,11 +6270,18 @@
           <a:solidFill>
             <a:srgbClr val="FFFFFF"/>
           </a:solidFill>
-          <a:ln w="12700">
+          <a:ln w="10160">
             <a:solidFill>
-              <a:srgbClr val="DCE2D8"/>
+              <a:srgbClr val="DBE2DC"/>
             </a:solidFill>
           </a:ln>
+          <a:effectLst>
+            <a:outerShdw blurRad="63500" dist="25400" dir="2700000" algn="ctr" rotWithShape="0">
+              <a:srgbClr val="0F1D26">
+                <a:alpha val="18000"/>
+              </a:srgbClr>
+            </a:outerShdw>
+          </a:effectLst>
         </p:spPr>
         <p:style>
           <a:lnRef idx="1">
@@ -6823,6 +6953,9 @@
   <p:clrMapOvr>
     <a:masterClrMapping/>
   </p:clrMapOvr>
+  <p:transition spd="med" advClick="1" dur="700">
+    <p:fade/>
+  </p:transition>
 </p:sld>
 </file>
 
@@ -7118,11 +7251,18 @@
           <a:solidFill>
             <a:srgbClr val="FFFFFF"/>
           </a:solidFill>
-          <a:ln w="12700">
+          <a:ln w="10160">
             <a:solidFill>
-              <a:srgbClr val="DCE2D8"/>
+              <a:srgbClr val="DBE2DC"/>
             </a:solidFill>
           </a:ln>
+          <a:effectLst>
+            <a:outerShdw blurRad="63500" dist="25400" dir="2700000" algn="ctr" rotWithShape="0">
+              <a:srgbClr val="0F1D26">
+                <a:alpha val="18000"/>
+              </a:srgbClr>
+            </a:outerShdw>
+          </a:effectLst>
         </p:spPr>
         <p:style>
           <a:lnRef idx="1">
@@ -7354,11 +7494,18 @@
           <a:solidFill>
             <a:srgbClr val="FFFFFF"/>
           </a:solidFill>
-          <a:ln w="12700">
+          <a:ln w="10160">
             <a:solidFill>
-              <a:srgbClr val="DCE2D8"/>
+              <a:srgbClr val="DBE2DC"/>
             </a:solidFill>
           </a:ln>
+          <a:effectLst>
+            <a:outerShdw blurRad="63500" dist="25400" dir="2700000" algn="ctr" rotWithShape="0">
+              <a:srgbClr val="0F1D26">
+                <a:alpha val="18000"/>
+              </a:srgbClr>
+            </a:outerShdw>
+          </a:effectLst>
         </p:spPr>
         <p:style>
           <a:lnRef idx="1">
@@ -7590,11 +7737,18 @@
           <a:solidFill>
             <a:srgbClr val="FFFFFF"/>
           </a:solidFill>
-          <a:ln w="12700">
+          <a:ln w="10160">
             <a:solidFill>
-              <a:srgbClr val="DCE2D8"/>
+              <a:srgbClr val="DBE2DC"/>
             </a:solidFill>
           </a:ln>
+          <a:effectLst>
+            <a:outerShdw blurRad="63500" dist="25400" dir="2700000" algn="ctr" rotWithShape="0">
+              <a:srgbClr val="0F1D26">
+                <a:alpha val="18000"/>
+              </a:srgbClr>
+            </a:outerShdw>
+          </a:effectLst>
         </p:spPr>
         <p:style>
           <a:lnRef idx="1">
@@ -8139,6 +8293,9 @@
   <p:clrMapOvr>
     <a:masterClrMapping/>
   </p:clrMapOvr>
+  <p:transition spd="med" advClick="1" dur="700">
+    <p:fade/>
+  </p:transition>
 </p:sld>
 </file>
 
@@ -8982,6 +9139,9 @@
   <p:clrMapOvr>
     <a:masterClrMapping/>
   </p:clrMapOvr>
+  <p:transition spd="med" advClick="1" dur="850">
+    <p:fade/>
+  </p:transition>
 </p:sld>
 </file>
 

</xml_diff>